<commit_message>
ppi made the final filtered df
</commit_message>
<xml_diff>
--- a/ppi/ppi-project.pptx
+++ b/ppi/ppi-project.pptx
@@ -202,7 +202,7 @@
           <a:p>
             <a:fld id="{93867FB6-3614-4446-A537-B153597F3F7D}" type="datetimeFigureOut">
               <a:rPr lang="nl-NL" smtClean="0"/>
-              <a:t>10-10-2023</a:t>
+              <a:t>14-10-2023</a:t>
             </a:fld>
             <a:endParaRPr lang="nl-NL"/>
           </a:p>
@@ -616,7 +616,7 @@
           <a:p>
             <a:fld id="{68957F31-EF9F-422B-9EBC-20B94937EE59}" type="datetimeFigureOut">
               <a:rPr lang="nl-NL" smtClean="0"/>
-              <a:t>10-10-2023</a:t>
+              <a:t>14-10-2023</a:t>
             </a:fld>
             <a:endParaRPr lang="nl-NL"/>
           </a:p>
@@ -814,7 +814,7 @@
           <a:p>
             <a:fld id="{68957F31-EF9F-422B-9EBC-20B94937EE59}" type="datetimeFigureOut">
               <a:rPr lang="nl-NL" smtClean="0"/>
-              <a:t>10-10-2023</a:t>
+              <a:t>14-10-2023</a:t>
             </a:fld>
             <a:endParaRPr lang="nl-NL"/>
           </a:p>
@@ -1022,7 +1022,7 @@
           <a:p>
             <a:fld id="{68957F31-EF9F-422B-9EBC-20B94937EE59}" type="datetimeFigureOut">
               <a:rPr lang="nl-NL" smtClean="0"/>
-              <a:t>10-10-2023</a:t>
+              <a:t>14-10-2023</a:t>
             </a:fld>
             <a:endParaRPr lang="nl-NL"/>
           </a:p>
@@ -1220,7 +1220,7 @@
           <a:p>
             <a:fld id="{68957F31-EF9F-422B-9EBC-20B94937EE59}" type="datetimeFigureOut">
               <a:rPr lang="nl-NL" smtClean="0"/>
-              <a:t>10-10-2023</a:t>
+              <a:t>14-10-2023</a:t>
             </a:fld>
             <a:endParaRPr lang="nl-NL"/>
           </a:p>
@@ -1495,7 +1495,7 @@
           <a:p>
             <a:fld id="{68957F31-EF9F-422B-9EBC-20B94937EE59}" type="datetimeFigureOut">
               <a:rPr lang="nl-NL" smtClean="0"/>
-              <a:t>10-10-2023</a:t>
+              <a:t>14-10-2023</a:t>
             </a:fld>
             <a:endParaRPr lang="nl-NL"/>
           </a:p>
@@ -1760,7 +1760,7 @@
           <a:p>
             <a:fld id="{68957F31-EF9F-422B-9EBC-20B94937EE59}" type="datetimeFigureOut">
               <a:rPr lang="nl-NL" smtClean="0"/>
-              <a:t>10-10-2023</a:t>
+              <a:t>14-10-2023</a:t>
             </a:fld>
             <a:endParaRPr lang="nl-NL"/>
           </a:p>
@@ -2172,7 +2172,7 @@
           <a:p>
             <a:fld id="{68957F31-EF9F-422B-9EBC-20B94937EE59}" type="datetimeFigureOut">
               <a:rPr lang="nl-NL" smtClean="0"/>
-              <a:t>10-10-2023</a:t>
+              <a:t>14-10-2023</a:t>
             </a:fld>
             <a:endParaRPr lang="nl-NL"/>
           </a:p>
@@ -2313,7 +2313,7 @@
           <a:p>
             <a:fld id="{68957F31-EF9F-422B-9EBC-20B94937EE59}" type="datetimeFigureOut">
               <a:rPr lang="nl-NL" smtClean="0"/>
-              <a:t>10-10-2023</a:t>
+              <a:t>14-10-2023</a:t>
             </a:fld>
             <a:endParaRPr lang="nl-NL"/>
           </a:p>
@@ -2426,7 +2426,7 @@
           <a:p>
             <a:fld id="{68957F31-EF9F-422B-9EBC-20B94937EE59}" type="datetimeFigureOut">
               <a:rPr lang="nl-NL" smtClean="0"/>
-              <a:t>10-10-2023</a:t>
+              <a:t>14-10-2023</a:t>
             </a:fld>
             <a:endParaRPr lang="nl-NL"/>
           </a:p>
@@ -2737,7 +2737,7 @@
           <a:p>
             <a:fld id="{68957F31-EF9F-422B-9EBC-20B94937EE59}" type="datetimeFigureOut">
               <a:rPr lang="nl-NL" smtClean="0"/>
-              <a:t>10-10-2023</a:t>
+              <a:t>14-10-2023</a:t>
             </a:fld>
             <a:endParaRPr lang="nl-NL"/>
           </a:p>
@@ -3025,7 +3025,7 @@
           <a:p>
             <a:fld id="{68957F31-EF9F-422B-9EBC-20B94937EE59}" type="datetimeFigureOut">
               <a:rPr lang="nl-NL" smtClean="0"/>
-              <a:t>10-10-2023</a:t>
+              <a:t>14-10-2023</a:t>
             </a:fld>
             <a:endParaRPr lang="nl-NL"/>
           </a:p>
@@ -3266,7 +3266,7 @@
           <a:p>
             <a:fld id="{68957F31-EF9F-422B-9EBC-20B94937EE59}" type="datetimeFigureOut">
               <a:rPr lang="nl-NL" smtClean="0"/>
-              <a:t>10-10-2023</a:t>
+              <a:t>14-10-2023</a:t>
             </a:fld>
             <a:endParaRPr lang="nl-NL"/>
           </a:p>
@@ -3827,7 +3827,7 @@
                 <a:latin typeface="Arial" panose="020B0604020202020204" pitchFamily="34" charset="0"/>
                 <a:cs typeface="Arial" panose="020B0604020202020204" pitchFamily="34" charset="0"/>
               </a:rPr>
-              <a:t>OMNIPATH</a:t>
+              <a:t>STRING</a:t>
             </a:r>
           </a:p>
           <a:p>
@@ -3837,7 +3837,7 @@
                 <a:latin typeface="Arial" panose="020B0604020202020204" pitchFamily="34" charset="0"/>
                 <a:cs typeface="Arial" panose="020B0604020202020204" pitchFamily="34" charset="0"/>
               </a:rPr>
-              <a:t>PSICQUIC</a:t>
+              <a:t>IntAct</a:t>
             </a:r>
           </a:p>
           <a:p>
@@ -3847,7 +3847,7 @@
                 <a:latin typeface="Arial" panose="020B0604020202020204" pitchFamily="34" charset="0"/>
                 <a:cs typeface="Arial" panose="020B0604020202020204" pitchFamily="34" charset="0"/>
               </a:rPr>
-              <a:t>STRING</a:t>
+              <a:t>BioGrid</a:t>
             </a:r>
           </a:p>
           <a:p>
@@ -3978,8 +3978,8 @@
         </p:nvSpPr>
         <p:spPr>
           <a:xfrm>
-            <a:off x="1621234" y="2589555"/>
-            <a:ext cx="1247457" cy="307777"/>
+            <a:off x="1545545" y="2604942"/>
+            <a:ext cx="1576072" cy="276999"/>
           </a:xfrm>
           <a:prstGeom prst="rect">
             <a:avLst/>
@@ -3994,11 +3994,11 @@
           <a:p>
             <a:pPr algn="ctr"/>
             <a:r>
-              <a:rPr lang="en-US" sz="1400" b="1" dirty="0">
+              <a:rPr lang="en-US" sz="1200" b="1" dirty="0">
                 <a:latin typeface="Arial" panose="020B0604020202020204" pitchFamily="34" charset="0"/>
                 <a:cs typeface="Arial" panose="020B0604020202020204" pitchFamily="34" charset="0"/>
               </a:rPr>
-              <a:t>Db selection</a:t>
+              <a:t>Database selection</a:t>
             </a:r>
           </a:p>
         </p:txBody>
@@ -4123,8 +4123,8 @@
         </p:nvSpPr>
         <p:spPr>
           <a:xfrm>
-            <a:off x="5090180" y="2589556"/>
-            <a:ext cx="1149418" cy="307777"/>
+            <a:off x="5149484" y="2599301"/>
+            <a:ext cx="1005403" cy="276999"/>
           </a:xfrm>
           <a:prstGeom prst="rect">
             <a:avLst/>
@@ -4139,11 +4139,11 @@
           <a:p>
             <a:pPr algn="ctr"/>
             <a:r>
-              <a:rPr lang="en-US" sz="1400" b="1" dirty="0">
+              <a:rPr lang="en-US" sz="1200" b="1" dirty="0">
                 <a:latin typeface="Arial" panose="020B0604020202020204" pitchFamily="34" charset="0"/>
                 <a:cs typeface="Arial" panose="020B0604020202020204" pitchFamily="34" charset="0"/>
               </a:rPr>
-              <a:t>Verification</a:t>
+              <a:t>verification</a:t>
             </a:r>
           </a:p>
         </p:txBody>
@@ -4366,8 +4366,8 @@
         </p:nvSpPr>
         <p:spPr>
           <a:xfrm>
-            <a:off x="6809629" y="2589556"/>
-            <a:ext cx="832279" cy="307777"/>
+            <a:off x="6855315" y="2589556"/>
+            <a:ext cx="740907" cy="276999"/>
           </a:xfrm>
           <a:prstGeom prst="rect">
             <a:avLst/>
@@ -4382,12 +4382,16 @@
           <a:p>
             <a:pPr algn="ctr"/>
             <a:r>
-              <a:rPr lang="en-US" sz="1400" b="1" dirty="0">
+              <a:rPr lang="en-US" sz="1200" b="1" dirty="0">
                 <a:latin typeface="Arial" panose="020B0604020202020204" pitchFamily="34" charset="0"/>
                 <a:cs typeface="Arial" panose="020B0604020202020204" pitchFamily="34" charset="0"/>
               </a:rPr>
               <a:t>UniProt</a:t>
             </a:r>
+            <a:endParaRPr lang="en-US" sz="1400" b="1" dirty="0">
+              <a:latin typeface="Arial" panose="020B0604020202020204" pitchFamily="34" charset="0"/>
+              <a:cs typeface="Arial" panose="020B0604020202020204" pitchFamily="34" charset="0"/>
+            </a:endParaRPr>
           </a:p>
         </p:txBody>
       </p:sp>
@@ -4459,8 +4463,8 @@
         </p:nvSpPr>
         <p:spPr>
           <a:xfrm>
-            <a:off x="8442657" y="2589555"/>
-            <a:ext cx="761748" cy="307777"/>
+            <a:off x="8482732" y="2589555"/>
+            <a:ext cx="681597" cy="276999"/>
           </a:xfrm>
           <a:prstGeom prst="rect">
             <a:avLst/>
@@ -4475,7 +4479,7 @@
           <a:p>
             <a:pPr algn="ctr"/>
             <a:r>
-              <a:rPr lang="en-US" sz="1400" b="1" dirty="0">
+              <a:rPr lang="en-US" sz="1200" b="1" dirty="0">
                 <a:latin typeface="Arial" panose="020B0604020202020204" pitchFamily="34" charset="0"/>
                 <a:cs typeface="Arial" panose="020B0604020202020204" pitchFamily="34" charset="0"/>
               </a:rPr>
@@ -4651,8 +4655,8 @@
         </p:nvSpPr>
         <p:spPr>
           <a:xfrm>
-            <a:off x="3382093" y="2589554"/>
-            <a:ext cx="1406155" cy="307777"/>
+            <a:off x="3447517" y="2599301"/>
+            <a:ext cx="1234632" cy="276999"/>
           </a:xfrm>
           <a:prstGeom prst="rect">
             <a:avLst/>
@@ -4667,7 +4671,7 @@
           <a:p>
             <a:pPr algn="ctr"/>
             <a:r>
-              <a:rPr lang="en-US" sz="1400" b="1" dirty="0">
+              <a:rPr lang="en-US" sz="1200" b="1" dirty="0">
                 <a:latin typeface="Arial" panose="020B0604020202020204" pitchFamily="34" charset="0"/>
                 <a:cs typeface="Arial" panose="020B0604020202020204" pitchFamily="34" charset="0"/>
               </a:rPr>
@@ -4691,7 +4695,7 @@
         <p:spPr>
           <a:xfrm>
             <a:off x="1470976" y="3170470"/>
-            <a:ext cx="1681320" cy="738664"/>
+            <a:ext cx="1681320" cy="523220"/>
           </a:xfrm>
           <a:prstGeom prst="rect">
             <a:avLst/>
@@ -4703,6 +4707,16 @@
             <a:spAutoFit/>
           </a:bodyPr>
           <a:lstStyle/>
+          <a:p>
+            <a:pPr algn="ctr"/>
+            <a:r>
+              <a:rPr lang="en-US" sz="1400" dirty="0">
+                <a:latin typeface="Arial" panose="020B0604020202020204" pitchFamily="34" charset="0"/>
+                <a:cs typeface="Arial" panose="020B0604020202020204" pitchFamily="34" charset="0"/>
+              </a:rPr>
+              <a:t>Benchmark:</a:t>
+            </a:r>
+          </a:p>
           <a:p>
             <a:pPr algn="ctr"/>
             <a:r>
@@ -4711,26 +4725,6 @@
                 <a:cs typeface="Arial" panose="020B0604020202020204" pitchFamily="34" charset="0"/>
               </a:rPr>
               <a:t>Bajpai et al. 2020</a:t>
-            </a:r>
-          </a:p>
-          <a:p>
-            <a:pPr algn="ctr"/>
-            <a:r>
-              <a:rPr lang="en-US" sz="1400" dirty="0">
-                <a:latin typeface="Arial" panose="020B0604020202020204" pitchFamily="34" charset="0"/>
-                <a:cs typeface="Arial" panose="020B0604020202020204" pitchFamily="34" charset="0"/>
-              </a:rPr>
-              <a:t>&amp; </a:t>
-            </a:r>
-          </a:p>
-          <a:p>
-            <a:pPr algn="ctr"/>
-            <a:r>
-              <a:rPr lang="en-US" sz="1400" dirty="0">
-                <a:latin typeface="Arial" panose="020B0604020202020204" pitchFamily="34" charset="0"/>
-                <a:cs typeface="Arial" panose="020B0604020202020204" pitchFamily="34" charset="0"/>
-              </a:rPr>
-              <a:t>own experience</a:t>
             </a:r>
           </a:p>
         </p:txBody>

</xml_diff>

<commit_message>
added Danyang et al. 2022 GFP phago to heatmap
</commit_message>
<xml_diff>
--- a/ppi/ppi-project.pptx
+++ b/ppi/ppi-project.pptx
@@ -6250,7 +6250,15 @@
           <a:p>
             <a:r>
               <a:rPr lang="en-US" i="1" dirty="0"/>
-              <a:t>(low nr of not detected: S100a8, Hspa1a, Ccr2, Anxa1)</a:t>
+              <a:t>(low nr </a:t>
+            </a:r>
+            <a:r>
+              <a:rPr lang="en-US" i="1" dirty="0" err="1"/>
+              <a:t>oR</a:t>
+            </a:r>
+            <a:r>
+              <a:rPr lang="en-US" i="1" dirty="0"/>
+              <a:t> not detected: S100a8, Hspa1a, Ccr2, Anxa1)</a:t>
             </a:r>
             <a:endParaRPr lang="nl-NL" i="1" dirty="0"/>
           </a:p>

</xml_diff>